<commit_message>
chore(cctc): align submission package with CCTC Guide for Authors
- Add page numbers, title page affiliation/corresponding-address placeholders
- Generate separate editable Highlights docx with 'highlights' in filename
- Number main sections 1-5 per guide
- Increase figure DPI to 500 for line/halftone artwork
- Provide separate Figure_1..Figure_8 and Supplementary_Figure_S1 PNG files with captions
- Update submission zip layout (manuscript/figures/tables/supplementary/code+data)

Co-Authored-By: Tatsuki Onishi <bougtoir@gmail.com>
</commit_message>
<xml_diff>
--- a/rct-decomposition/KOTHA_Framework_CCTC_figures.pptx
+++ b/rct-decomposition/KOTHA_Framework_CCTC_figures.pptx
@@ -3143,7 +3143,7 @@
         <p:spPr>
           <a:xfrm>
             <a:off x="914400" y="1005840"/>
-            <a:ext cx="10362895" cy="7286614"/>
+            <a:ext cx="10362895" cy="7288448"/>
           </a:xfrm>
           <a:prstGeom prst="rect">
             <a:avLst/>
@@ -3247,7 +3247,7 @@
         <p:spPr>
           <a:xfrm>
             <a:off x="914400" y="1005840"/>
-            <a:ext cx="10362895" cy="4251668"/>
+            <a:ext cx="10362895" cy="4248175"/>
           </a:xfrm>
           <a:prstGeom prst="rect">
             <a:avLst/>
@@ -3351,7 +3351,7 @@
         <p:spPr>
           <a:xfrm>
             <a:off x="914400" y="1005840"/>
-            <a:ext cx="10362895" cy="4321228"/>
+            <a:ext cx="10362895" cy="4320020"/>
           </a:xfrm>
           <a:prstGeom prst="rect">
             <a:avLst/>
@@ -3455,7 +3455,7 @@
         <p:spPr>
           <a:xfrm>
             <a:off x="914400" y="1005840"/>
-            <a:ext cx="10362895" cy="10899869"/>
+            <a:ext cx="10362895" cy="10900820"/>
           </a:xfrm>
           <a:prstGeom prst="rect">
             <a:avLst/>
@@ -3559,7 +3559,7 @@
         <p:spPr>
           <a:xfrm>
             <a:off x="914400" y="1005840"/>
-            <a:ext cx="10362895" cy="6198729"/>
+            <a:ext cx="10362895" cy="6192822"/>
           </a:xfrm>
           <a:prstGeom prst="rect">
             <a:avLst/>
@@ -3663,7 +3663,7 @@
         <p:spPr>
           <a:xfrm>
             <a:off x="914400" y="1005840"/>
-            <a:ext cx="10362895" cy="9050518"/>
+            <a:ext cx="10362895" cy="9047105"/>
           </a:xfrm>
           <a:prstGeom prst="rect">
             <a:avLst/>
@@ -3767,7 +3767,7 @@
         <p:spPr>
           <a:xfrm>
             <a:off x="914400" y="1005840"/>
-            <a:ext cx="10362895" cy="4251668"/>
+            <a:ext cx="10362895" cy="4247460"/>
           </a:xfrm>
           <a:prstGeom prst="rect">
             <a:avLst/>
@@ -3871,7 +3871,7 @@
         <p:spPr>
           <a:xfrm>
             <a:off x="914400" y="1005840"/>
-            <a:ext cx="10362895" cy="4984347"/>
+            <a:ext cx="10362895" cy="4978424"/>
           </a:xfrm>
           <a:prstGeom prst="rect">
             <a:avLst/>

</xml_diff>

<commit_message>
Integrate figures/tables for CCTC: combine Mg+statins forest plot, split S1 trace, period abbreviations in refs
Co-Authored-By: Tatsuki Onishi <bougtoir@gmail.com>
</commit_message>
<xml_diff>
--- a/rct-decomposition/KOTHA_Framework_CCTC_figures.pptx
+++ b/rct-decomposition/KOTHA_Framework_CCTC_figures.pptx
@@ -12,7 +12,6 @@
     <p:sldId id="260" r:id="rId11"/>
     <p:sldId id="261" r:id="rId12"/>
     <p:sldId id="262" r:id="rId13"/>
-    <p:sldId id="263" r:id="rId14"/>
   </p:sldIdLst>
   <p:sldSz cx="12191695" cy="6858000" type="screen4x3"/>
   <p:notesSz cx="6858000" cy="9144000"/>
@@ -3440,7 +3439,7 @@
       </p:sp>
       <p:pic>
         <p:nvPicPr>
-          <p:cNvPr id="3" name="Picture 2" descr="fig4_forest_plot_mg.png"/>
+          <p:cNvPr id="3" name="Picture 2" descr="fig4_forest_combined.png"/>
           <p:cNvPicPr>
             <a:picLocks noChangeAspect="1"/>
           </p:cNvPicPr>
@@ -3455,7 +3454,7 @@
         <p:spPr>
           <a:xfrm>
             <a:off x="914400" y="1005840"/>
-            <a:ext cx="10362895" cy="10900820"/>
+            <a:ext cx="10362895" cy="5449819"/>
           </a:xfrm>
           <a:prstGeom prst="rect">
             <a:avLst/>
@@ -3488,7 +3487,7 @@
               <a:defRPr sz="1400"/>
             </a:pPr>
             <a:r>
-              <a:t>Figure 4. Forest plot for magnesium in AMI. Individual study odds ratios are shown with 95% confidence intervals, color-coded by era. Pooled estimates include frequentist random-effects (pre-ISIS-4 and all trials) and Bayesian integrated estimates at selected discounting levels (α = 0.3, 0.5, 1.0).</a:t>
+              <a:t>Figure 4. Forest plots for (A) magnesium in AMI and (B) statins in heart failure. Individual study effect estimates are shown with 95% confidence intervals. Pooled estimates include frequentist random-effects and Bayesian integrated estimates at selected discounting levels (α = 0.3, 0.5, 1.0 for magnesium; 0.1, 0.3, 0.5 for statins).</a:t>
             </a:r>
           </a:p>
         </p:txBody>
@@ -3648,7 +3647,7 @@
       </p:sp>
       <p:pic>
         <p:nvPicPr>
-          <p:cNvPr id="3" name="Picture 2" descr="fig6_forest_statins.png"/>
+          <p:cNvPr id="3" name="Picture 2" descr="fig7_sensitivity_analysis.png"/>
           <p:cNvPicPr>
             <a:picLocks noChangeAspect="1"/>
           </p:cNvPicPr>
@@ -3663,7 +3662,7 @@
         <p:spPr>
           <a:xfrm>
             <a:off x="914400" y="1005840"/>
-            <a:ext cx="10362895" cy="9047105"/>
+            <a:ext cx="10362895" cy="4247460"/>
           </a:xfrm>
           <a:prstGeom prst="rect">
             <a:avLst/>
@@ -3696,7 +3695,7 @@
               <a:defRPr sz="1400"/>
             </a:pPr>
             <a:r>
-              <a:t>Figure 6. Forest plot for statins in heart failure. Individual study hazard ratios are shown with 95% confidence intervals, grouped by design. Pooled estimates include design-specific frequentist pooling and KOTHA-integrated estimates at selected discounting levels (α = 0.1, 0.3, 0.5).</a:t>
+              <a:t>Figure 6. Sensitivity analysis of Bayesian integration to the discounting parameter α. (A) Magnesium in AMI. (B) Statins in HF. Three posterior probability thresholds are shown: P(effect &lt; 1.0), P(effect &lt; 0.90), and P(effect &lt; 0.80). Horizontal dashed line indicates 95% probability.</a:t>
             </a:r>
           </a:p>
         </p:txBody>
@@ -3752,110 +3751,6 @@
       </p:sp>
       <p:pic>
         <p:nvPicPr>
-          <p:cNvPr id="3" name="Picture 2" descr="fig7_sensitivity_analysis.png"/>
-          <p:cNvPicPr>
-            <a:picLocks noChangeAspect="1"/>
-          </p:cNvPicPr>
-          <p:nvPr/>
-        </p:nvPicPr>
-        <p:blipFill>
-          <a:blip r:embed="rId2"/>
-          <a:stretch>
-            <a:fillRect/>
-          </a:stretch>
-        </p:blipFill>
-        <p:spPr>
-          <a:xfrm>
-            <a:off x="914400" y="1005840"/>
-            <a:ext cx="10362895" cy="4247460"/>
-          </a:xfrm>
-          <a:prstGeom prst="rect">
-            <a:avLst/>
-          </a:prstGeom>
-        </p:spPr>
-      </p:pic>
-      <p:sp>
-        <p:nvSpPr>
-          <p:cNvPr id="4" name="TextBox 3"/>
-          <p:cNvSpPr txBox="1"/>
-          <p:nvPr/>
-        </p:nvSpPr>
-        <p:spPr>
-          <a:xfrm>
-            <a:off x="457200" y="5943600"/>
-            <a:ext cx="11277295" cy="914400"/>
-          </a:xfrm>
-          <a:prstGeom prst="rect">
-            <a:avLst/>
-          </a:prstGeom>
-          <a:noFill/>
-        </p:spPr>
-        <p:txBody>
-          <a:bodyPr wrap="none">
-            <a:spAutoFit/>
-          </a:bodyPr>
-          <a:lstStyle/>
-          <a:p>
-            <a:pPr algn="l">
-              <a:defRPr sz="1400"/>
-            </a:pPr>
-            <a:r>
-              <a:t>Figure 7. Sensitivity analysis of Bayesian integration to the discounting parameter α. (A) Magnesium in AMI. (B) Statins in HF. Three posterior probability thresholds are shown: P(effect &lt; 1.0), P(effect &lt; 0.90), and P(effect &lt; 0.80). Horizontal dashed line indicates 95% probability.</a:t>
-            </a:r>
-          </a:p>
-        </p:txBody>
-      </p:sp>
-    </p:spTree>
-  </p:cSld>
-  <p:clrMapOvr>
-    <a:masterClrMapping/>
-  </p:clrMapOvr>
-</p:sld>
-</file>
-
-<file path=ppt/slides/slide8.xml><?xml version="1.0" encoding="utf-8"?>
-<p:sld xmlns:a="http://schemas.openxmlformats.org/drawingml/2006/main" xmlns:p="http://schemas.openxmlformats.org/presentationml/2006/main" xmlns:r="http://schemas.openxmlformats.org/officeDocument/2006/relationships">
-  <p:cSld>
-    <p:spTree>
-      <p:nvGrpSpPr>
-        <p:cNvPr id="1" name=""/>
-        <p:cNvGrpSpPr/>
-        <p:nvPr/>
-      </p:nvGrpSpPr>
-      <p:grpSpPr/>
-      <p:sp>
-        <p:nvSpPr>
-          <p:cNvPr id="2" name="TextBox 1"/>
-          <p:cNvSpPr txBox="1"/>
-          <p:nvPr/>
-        </p:nvSpPr>
-        <p:spPr>
-          <a:xfrm>
-            <a:off x="457200" y="274320"/>
-            <a:ext cx="11277295" cy="548640"/>
-          </a:xfrm>
-          <a:prstGeom prst="rect">
-            <a:avLst/>
-          </a:prstGeom>
-          <a:noFill/>
-        </p:spPr>
-        <p:txBody>
-          <a:bodyPr wrap="none">
-            <a:spAutoFit/>
-          </a:bodyPr>
-          <a:lstStyle/>
-          <a:p>
-            <a:pPr algn="ctr">
-              <a:defRPr sz="2400" b="1"/>
-            </a:pPr>
-            <a:r>
-              <a:t>Figure 8</a:t>
-            </a:r>
-          </a:p>
-        </p:txBody>
-      </p:sp>
-      <p:pic>
-        <p:nvPicPr>
           <p:cNvPr id="3" name="Picture 2" descr="fig8_module_h_comparison.png"/>
           <p:cNvPicPr>
             <a:picLocks noChangeAspect="1"/>
@@ -3904,7 +3799,7 @@
               <a:defRPr sz="1400"/>
             </a:pPr>
             <a:r>
-              <a:t>Figure 8. Module H assessment comparison: standard GRADE vs. KOTHA-enhanced evaluation for both illustrative cases. Color coding indicates severity of concern (green = no concern, yellow = moderate, red = serious).</a:t>
+              <a:t>Figure 7. Module H assessment comparison: standard GRADE vs. KOTHA-enhanced evaluation for both illustrative cases. Color coding indicates severity of concern (green = no concern, yellow = moderate, red = serious).</a:t>
             </a:r>
           </a:p>
         </p:txBody>

</xml_diff>

<commit_message>
fix: Clinical Trials submission checks - cross-references, Word OMML math, real refs, no double-byte chars, causal language, sanitize office outputs, reproducibility
Co-Authored-By: Tatsuki Onishi <bougtoir@gmail.com>
</commit_message>
<xml_diff>
--- a/rct-decomposition/KOTHA_Framework_CCTC_figures.pptx
+++ b/rct-decomposition/KOTHA_Framework_CCTC_figures.pptx
@@ -336,7 +336,7 @@
           <a:p>
             <a:fld id="{C1FF6DA9-008F-8B48-92A6-B652298478BF}" type="slidenum">
               <a:rPr lang="en-US" smtClean="0"/>
-              <a:t>‹#›</a:t>
+              <a:t>#</a:t>
             </a:fld>
             <a:endParaRPr lang="en-US"/>
           </a:p>
@@ -506,7 +506,7 @@
           <a:p>
             <a:fld id="{C1FF6DA9-008F-8B48-92A6-B652298478BF}" type="slidenum">
               <a:rPr lang="en-US" smtClean="0"/>
-              <a:t>‹#›</a:t>
+              <a:t>#</a:t>
             </a:fld>
             <a:endParaRPr lang="en-US"/>
           </a:p>
@@ -686,7 +686,7 @@
           <a:p>
             <a:fld id="{C1FF6DA9-008F-8B48-92A6-B652298478BF}" type="slidenum">
               <a:rPr lang="en-US" smtClean="0"/>
-              <a:t>‹#›</a:t>
+              <a:t>#</a:t>
             </a:fld>
             <a:endParaRPr lang="en-US"/>
           </a:p>
@@ -856,7 +856,7 @@
           <a:p>
             <a:fld id="{C1FF6DA9-008F-8B48-92A6-B652298478BF}" type="slidenum">
               <a:rPr lang="en-US" smtClean="0"/>
-              <a:t>‹#›</a:t>
+              <a:t>#</a:t>
             </a:fld>
             <a:endParaRPr lang="en-US"/>
           </a:p>
@@ -1102,7 +1102,7 @@
           <a:p>
             <a:fld id="{C1FF6DA9-008F-8B48-92A6-B652298478BF}" type="slidenum">
               <a:rPr lang="en-US" smtClean="0"/>
-              <a:t>‹#›</a:t>
+              <a:t>#</a:t>
             </a:fld>
             <a:endParaRPr lang="en-US"/>
           </a:p>
@@ -1390,7 +1390,7 @@
           <a:p>
             <a:fld id="{C1FF6DA9-008F-8B48-92A6-B652298478BF}" type="slidenum">
               <a:rPr lang="en-US" smtClean="0"/>
-              <a:t>‹#›</a:t>
+              <a:t>#</a:t>
             </a:fld>
             <a:endParaRPr lang="en-US"/>
           </a:p>
@@ -1812,7 +1812,7 @@
           <a:p>
             <a:fld id="{C1FF6DA9-008F-8B48-92A6-B652298478BF}" type="slidenum">
               <a:rPr lang="en-US" smtClean="0"/>
-              <a:t>‹#›</a:t>
+              <a:t>#</a:t>
             </a:fld>
             <a:endParaRPr lang="en-US"/>
           </a:p>
@@ -1930,7 +1930,7 @@
           <a:p>
             <a:fld id="{C1FF6DA9-008F-8B48-92A6-B652298478BF}" type="slidenum">
               <a:rPr lang="en-US" smtClean="0"/>
-              <a:t>‹#›</a:t>
+              <a:t>#</a:t>
             </a:fld>
             <a:endParaRPr lang="en-US"/>
           </a:p>
@@ -2025,7 +2025,7 @@
           <a:p>
             <a:fld id="{C1FF6DA9-008F-8B48-92A6-B652298478BF}" type="slidenum">
               <a:rPr lang="en-US" smtClean="0"/>
-              <a:t>‹#›</a:t>
+              <a:t>#</a:t>
             </a:fld>
             <a:endParaRPr lang="en-US"/>
           </a:p>
@@ -2302,7 +2302,7 @@
           <a:p>
             <a:fld id="{C1FF6DA9-008F-8B48-92A6-B652298478BF}" type="slidenum">
               <a:rPr lang="en-US" smtClean="0"/>
-              <a:t>‹#›</a:t>
+              <a:t>#</a:t>
             </a:fld>
             <a:endParaRPr lang="en-US"/>
           </a:p>
@@ -2555,7 +2555,7 @@
           <a:p>
             <a:fld id="{C1FF6DA9-008F-8B48-92A6-B652298478BF}" type="slidenum">
               <a:rPr lang="en-US" smtClean="0"/>
-              <a:t>‹#›</a:t>
+              <a:t>#</a:t>
             </a:fld>
             <a:endParaRPr lang="en-US"/>
           </a:p>
@@ -2804,7 +2804,7 @@
           <a:p>
             <a:fld id="{C1FF6DA9-008F-8B48-92A6-B652298478BF}" type="slidenum">
               <a:rPr lang="en-US" smtClean="0"/>
-              <a:t>‹#›</a:t>
+              <a:t>#</a:t>
             </a:fld>
             <a:endParaRPr lang="en-US"/>
           </a:p>
@@ -2854,7 +2854,7 @@
           <a:spcPct val="20000"/>
         </a:spcBef>
         <a:buFont typeface="Arial"/>
-        <a:buChar char="•"/>
+        <a:buChar char="-"/>
         <a:defRPr sz="3200" kern="1200">
           <a:solidFill>
             <a:schemeClr val="tx1"/>
@@ -2869,7 +2869,7 @@
           <a:spcPct val="20000"/>
         </a:spcBef>
         <a:buFont typeface="Arial"/>
-        <a:buChar char="–"/>
+        <a:buChar char="-"/>
         <a:defRPr sz="2800" kern="1200">
           <a:solidFill>
             <a:schemeClr val="tx1"/>
@@ -2884,7 +2884,7 @@
           <a:spcPct val="20000"/>
         </a:spcBef>
         <a:buFont typeface="Arial"/>
-        <a:buChar char="•"/>
+        <a:buChar char="-"/>
         <a:defRPr sz="2400" kern="1200">
           <a:solidFill>
             <a:schemeClr val="tx1"/>
@@ -2899,7 +2899,7 @@
           <a:spcPct val="20000"/>
         </a:spcBef>
         <a:buFont typeface="Arial"/>
-        <a:buChar char="–"/>
+        <a:buChar char="-"/>
         <a:defRPr sz="2000" kern="1200">
           <a:solidFill>
             <a:schemeClr val="tx1"/>
@@ -2914,7 +2914,7 @@
           <a:spcPct val="20000"/>
         </a:spcBef>
         <a:buFont typeface="Arial"/>
-        <a:buChar char="»"/>
+        <a:buChar char="&gt;&gt;"/>
         <a:defRPr sz="2000" kern="1200">
           <a:solidFill>
             <a:schemeClr val="tx1"/>
@@ -2929,7 +2929,7 @@
           <a:spcPct val="20000"/>
         </a:spcBef>
         <a:buFont typeface="Arial"/>
-        <a:buChar char="•"/>
+        <a:buChar char="-"/>
         <a:defRPr sz="2000" kern="1200">
           <a:solidFill>
             <a:schemeClr val="tx1"/>
@@ -2944,7 +2944,7 @@
           <a:spcPct val="20000"/>
         </a:spcBef>
         <a:buFont typeface="Arial"/>
-        <a:buChar char="•"/>
+        <a:buChar char="-"/>
         <a:defRPr sz="2000" kern="1200">
           <a:solidFill>
             <a:schemeClr val="tx1"/>
@@ -2959,7 +2959,7 @@
           <a:spcPct val="20000"/>
         </a:spcBef>
         <a:buFont typeface="Arial"/>
-        <a:buChar char="•"/>
+        <a:buChar char="-"/>
         <a:defRPr sz="2000" kern="1200">
           <a:solidFill>
             <a:schemeClr val="tx1"/>
@@ -2974,7 +2974,7 @@
           <a:spcPct val="20000"/>
         </a:spcBef>
         <a:buFont typeface="Arial"/>
-        <a:buChar char="•"/>
+        <a:buChar char="-"/>
         <a:defRPr sz="2000" kern="1200">
           <a:solidFill>
             <a:schemeClr val="tx1"/>
@@ -3454,7 +3454,7 @@
         <p:spPr>
           <a:xfrm>
             <a:off x="914400" y="1005840"/>
-            <a:ext cx="10362895" cy="5449819"/>
+            <a:ext cx="10362895" cy="5354658"/>
           </a:xfrm>
           <a:prstGeom prst="rect">
             <a:avLst/>
@@ -3487,7 +3487,7 @@
               <a:defRPr sz="1400"/>
             </a:pPr>
             <a:r>
-              <a:t>Figure 4. Forest plots for (A) magnesium in AMI and (B) statins in heart failure. Individual study effect estimates are shown with 95% confidence intervals. Pooled estimates include frequentist random-effects and Bayesian integrated estimates at selected discounting levels (α = 0.3, 0.5, 1.0 for magnesium; 0.1, 0.3, 0.5 for statins).</a:t>
+              <a:t>Figure 4. Forest plots for (A) magnesium in AMI and (B) statins in heart failure. Individual study effect estimates are shown with 95% confidence intervals. Pooled estimates include frequentist random-effects and Bayesian integrated estimates at selected discounting levels (alpha = 0.3, 0.5, 1.0 for magnesium; 0.1, 0.3, 0.5 for statins).</a:t>
             </a:r>
           </a:p>
         </p:txBody>
@@ -3695,7 +3695,7 @@
               <a:defRPr sz="1400"/>
             </a:pPr>
             <a:r>
-              <a:t>Figure 6. Sensitivity analysis of Bayesian integration to the discounting parameter α. (A) Magnesium in AMI. (B) Statins in HF. Three posterior probability thresholds are shown: P(effect &lt; 1.0), P(effect &lt; 0.90), and P(effect &lt; 0.80). Horizontal dashed line indicates 95% probability.</a:t>
+              <a:t>Figure 6. Sensitivity analysis of Bayesian integration to the discounting parameter alpha. (A) Magnesium in AMI. (B) Statins in HF. Three posterior probability thresholds are shown: P(effect &lt; 1.0), P(effect &lt; 0.90), and P(effect &lt; 0.80). Horizontal dashed line indicates 95% probability.</a:t>
             </a:r>
           </a:p>
         </p:txBody>
@@ -3858,10 +3858,10 @@
         <a:latin typeface="Calibri"/>
         <a:ea typeface=""/>
         <a:cs typeface=""/>
-        <a:font script="Jpan" typeface="ＭＳ Ｐゴシック"/>
-        <a:font script="Hang" typeface="맑은 고딕"/>
-        <a:font script="Hans" typeface="宋体"/>
-        <a:font script="Hant" typeface="新細明體"/>
+        <a:font script="Jpan" typeface="MS PGothic"/>
+        <a:font script="Hang" typeface="Malgun Gothic"/>
+        <a:font script="Hans" typeface="SimSun"/>
+        <a:font script="Hant" typeface="PMingLiU"/>
         <a:font script="Arab" typeface="Times New Roman"/>
         <a:font script="Hebr" typeface="Times New Roman"/>
         <a:font script="Thai" typeface="Angsana New"/>
@@ -3893,10 +3893,10 @@
         <a:latin typeface="Calibri"/>
         <a:ea typeface=""/>
         <a:cs typeface=""/>
-        <a:font script="Jpan" typeface="ＭＳ Ｐゴシック"/>
-        <a:font script="Hang" typeface="맑은 고딕"/>
-        <a:font script="Hans" typeface="宋体"/>
-        <a:font script="Hant" typeface="新細明體"/>
+        <a:font script="Jpan" typeface="MS PGothic"/>
+        <a:font script="Hang" typeface="Malgun Gothic"/>
+        <a:font script="Hans" typeface="SimSun"/>
+        <a:font script="Hant" typeface="PMingLiU"/>
         <a:font script="Arab" typeface="Arial"/>
         <a:font script="Hebr" typeface="Arial"/>
         <a:font script="Thai" typeface="Cordia New"/>

</xml_diff>

<commit_message>
Add formal causal model and operating-characteristics simulation for KOTHA; update CCTC manuscript title; sync workflow mapping for new branch
Co-Authored-By: Tatsuki Onishi <bougtoir@gmail.com>
</commit_message>
<xml_diff>
--- a/rct-decomposition/KOTHA_Framework_CCTC_figures.pptx
+++ b/rct-decomposition/KOTHA_Framework_CCTC_figures.pptx
@@ -12,6 +12,7 @@
     <p:sldId id="260" r:id="rId11"/>
     <p:sldId id="261" r:id="rId12"/>
     <p:sldId id="262" r:id="rId13"/>
+    <p:sldId id="263" r:id="rId14"/>
   </p:sldIdLst>
   <p:sldSz cx="12191695" cy="6858000" type="screen4x3"/>
   <p:notesSz cx="6858000" cy="9144000"/>
@@ -3800,6 +3801,110 @@
             </a:pPr>
             <a:r>
               <a:t>Figure 7. Module H assessment comparison: standard GRADE vs. KOTHA-enhanced evaluation for both illustrative cases. Color coding indicates severity of concern (green = no concern, yellow = moderate, red = serious).</a:t>
+            </a:r>
+          </a:p>
+        </p:txBody>
+      </p:sp>
+    </p:spTree>
+  </p:cSld>
+  <p:clrMapOvr>
+    <a:masterClrMapping/>
+  </p:clrMapOvr>
+</p:sld>
+</file>
+
+<file path=ppt/slides/slide8.xml><?xml version="1.0" encoding="utf-8"?>
+<p:sld xmlns:a="http://schemas.openxmlformats.org/drawingml/2006/main" xmlns:p="http://schemas.openxmlformats.org/presentationml/2006/main" xmlns:r="http://schemas.openxmlformats.org/officeDocument/2006/relationships">
+  <p:cSld>
+    <p:spTree>
+      <p:nvGrpSpPr>
+        <p:cNvPr id="1" name=""/>
+        <p:cNvGrpSpPr/>
+        <p:nvPr/>
+      </p:nvGrpSpPr>
+      <p:grpSpPr/>
+      <p:sp>
+        <p:nvSpPr>
+          <p:cNvPr id="2" name="TextBox 1"/>
+          <p:cNvSpPr txBox="1"/>
+          <p:nvPr/>
+        </p:nvSpPr>
+        <p:spPr>
+          <a:xfrm>
+            <a:off x="457200" y="274320"/>
+            <a:ext cx="11277295" cy="548640"/>
+          </a:xfrm>
+          <a:prstGeom prst="rect">
+            <a:avLst/>
+          </a:prstGeom>
+          <a:noFill/>
+        </p:spPr>
+        <p:txBody>
+          <a:bodyPr wrap="none">
+            <a:spAutoFit/>
+          </a:bodyPr>
+          <a:lstStyle/>
+          <a:p>
+            <a:pPr algn="ctr">
+              <a:defRPr sz="2400" b="1"/>
+            </a:pPr>
+            <a:r>
+              <a:t>Figure 8</a:t>
+            </a:r>
+          </a:p>
+        </p:txBody>
+      </p:sp>
+      <p:pic>
+        <p:nvPicPr>
+          <p:cNvPr id="3" name="Picture 2" descr="fig_simulation_operating_characteristics.png"/>
+          <p:cNvPicPr>
+            <a:picLocks noChangeAspect="1"/>
+          </p:cNvPicPr>
+          <p:nvPr/>
+        </p:nvPicPr>
+        <p:blipFill>
+          <a:blip r:embed="rId2"/>
+          <a:stretch>
+            <a:fillRect/>
+          </a:stretch>
+        </p:blipFill>
+        <p:spPr>
+          <a:xfrm>
+            <a:off x="914400" y="1005840"/>
+            <a:ext cx="10362895" cy="7946551"/>
+          </a:xfrm>
+          <a:prstGeom prst="rect">
+            <a:avLst/>
+          </a:prstGeom>
+        </p:spPr>
+      </p:pic>
+      <p:sp>
+        <p:nvSpPr>
+          <p:cNvPr id="4" name="TextBox 3"/>
+          <p:cNvSpPr txBox="1"/>
+          <p:nvPr/>
+        </p:nvSpPr>
+        <p:spPr>
+          <a:xfrm>
+            <a:off x="457200" y="5943600"/>
+            <a:ext cx="11277295" cy="914400"/>
+          </a:xfrm>
+          <a:prstGeom prst="rect">
+            <a:avLst/>
+          </a:prstGeom>
+          <a:noFill/>
+        </p:spPr>
+        <p:txBody>
+          <a:bodyPr wrap="none">
+            <a:spAutoFit/>
+          </a:bodyPr>
+          <a:lstStyle/>
+          <a:p>
+            <a:pPr algn="l">
+              <a:defRPr sz="1400"/>
+            </a:pPr>
+            <a:r>
+              <a:t>Figure 8. Operating characteristics of the simulation study. (A) Bias and RMSE for the target, RCT-enrolled-only, observational-only, fixed KOTHA (α = 0.3), and RMSE-optimal KOTHA estimators. (B) Coverage and power. Error bars in A show RMSE around the bias estimate; coverage and power are empirical proportions across replications.</a:t>
             </a:r>
           </a:p>
         </p:txBody>

</xml_diff>